<commit_message>
LUBE OFFICE: motor no ar, altura do editor, modelos em pt-BR e teste do motor
Teste de ponta a ponta com o motor da SRV-IA (ONLYOFFICE 10.0): abriu,
editou, fechou e a versao 2 chegou com origem "editor" e o texto escrito.
O teste achou e este commit corrige:
- editor.css: o ONLYOFFICE troca o espaco reservado pela propria moldura,
  que ficava com 150 px; .ed-area > iframe ocupa a area toda.
- Modelos: idioma pt-BR (o corretor sublinhava tudo em ingles) e
  propriedades da Lube no lugar de "python-docx", data de 2013 e
  "Microsoft Macintosh Word" (gerar_modelos.py, funcao finalizar).
Tambem: porta POST /office/motor/teste, so com senha temporaria gravada no
banco (db/06_office_teste_motor.sql), para conferir o motor depois de
instalar ou reinstalar.

Co-Authored-By: Claude Opus 5.5 <noreply@anthropic.com>
</commit_message>
<xml_diff>
--- a/office/modelos/apresentacao-lube.pptx
+++ b/office/modelos/apresentacao-lube.pptx
@@ -15,7 +15,7 @@
   <p:notesSz cx="6858000" cy="9144000"/>
   <p:defaultTextStyle>
     <a:defPPr>
-      <a:defRPr lang="en-US"/>
+      <a:defRPr lang="pt-BR"/>
     </a:defPPr>
     <a:lvl1pPr marL="0" algn="l" defTabSz="457200" rtl="0" eaLnBrk="1" latinLnBrk="0" hangingPunct="1">
       <a:defRPr sz="1800" kern="1200">
@@ -149,10 +149,10 @@
           <a:lstStyle/>
           <a:p>
             <a:r>
-              <a:rPr lang="en-US" smtClean="0"/>
+              <a:rPr lang="pt-BR" smtClean="0"/>
               <a:t>Click to edit Master title style</a:t>
             </a:r>
-            <a:endParaRPr lang="en-US"/>
+            <a:endParaRPr lang="pt-BR"/>
           </a:p>
         </p:txBody>
       </p:sp>
@@ -268,10 +268,10 @@
           </a:lstStyle>
           <a:p>
             <a:r>
-              <a:rPr lang="en-US" smtClean="0"/>
+              <a:rPr lang="pt-BR" smtClean="0"/>
               <a:t>Click to edit Master subtitle style</a:t>
             </a:r>
-            <a:endParaRPr lang="en-US"/>
+            <a:endParaRPr lang="pt-BR"/>
           </a:p>
         </p:txBody>
       </p:sp>
@@ -291,10 +291,10 @@
           <a:lstStyle/>
           <a:p>
             <a:fld id="{5BCAD085-E8A6-8845-BD4E-CB4CCA059FC4}" type="datetimeFigureOut">
-              <a:rPr lang="en-US" smtClean="0"/>
+              <a:rPr lang="pt-BR" smtClean="0"/>
               <a:t>1/27/13</a:t>
             </a:fld>
-            <a:endParaRPr lang="en-US"/>
+            <a:endParaRPr lang="pt-BR"/>
           </a:p>
         </p:txBody>
       </p:sp>
@@ -313,7 +313,7 @@
           <a:bodyPr/>
           <a:lstStyle/>
           <a:p>
-            <a:endParaRPr lang="en-US"/>
+            <a:endParaRPr lang="pt-BR"/>
           </a:p>
         </p:txBody>
       </p:sp>
@@ -333,10 +333,10 @@
           <a:lstStyle/>
           <a:p>
             <a:fld id="{C1FF6DA9-008F-8B48-92A6-B652298478BF}" type="slidenum">
-              <a:rPr lang="en-US" smtClean="0"/>
+              <a:rPr lang="pt-BR" smtClean="0"/>
               <a:t>‹#›</a:t>
             </a:fld>
-            <a:endParaRPr lang="en-US"/>
+            <a:endParaRPr lang="pt-BR"/>
           </a:p>
         </p:txBody>
       </p:sp>
@@ -386,10 +386,10 @@
           <a:lstStyle/>
           <a:p>
             <a:r>
-              <a:rPr lang="en-US" smtClean="0"/>
+              <a:rPr lang="pt-BR" smtClean="0"/>
               <a:t>Click to edit Master title style</a:t>
             </a:r>
-            <a:endParaRPr lang="en-US"/>
+            <a:endParaRPr lang="pt-BR"/>
           </a:p>
         </p:txBody>
       </p:sp>
@@ -410,38 +410,38 @@
           <a:p>
             <a:pPr lvl="0"/>
             <a:r>
-              <a:rPr lang="en-US" smtClean="0"/>
+              <a:rPr lang="pt-BR" smtClean="0"/>
               <a:t>Click to edit Master text styles</a:t>
             </a:r>
           </a:p>
           <a:p>
             <a:pPr lvl="1"/>
             <a:r>
-              <a:rPr lang="en-US" smtClean="0"/>
+              <a:rPr lang="pt-BR" smtClean="0"/>
               <a:t>Second level</a:t>
             </a:r>
           </a:p>
           <a:p>
             <a:pPr lvl="2"/>
             <a:r>
-              <a:rPr lang="en-US" smtClean="0"/>
+              <a:rPr lang="pt-BR" smtClean="0"/>
               <a:t>Third level</a:t>
             </a:r>
           </a:p>
           <a:p>
             <a:pPr lvl="3"/>
             <a:r>
-              <a:rPr lang="en-US" smtClean="0"/>
+              <a:rPr lang="pt-BR" smtClean="0"/>
               <a:t>Fourth level</a:t>
             </a:r>
           </a:p>
           <a:p>
             <a:pPr lvl="4"/>
             <a:r>
-              <a:rPr lang="en-US" smtClean="0"/>
+              <a:rPr lang="pt-BR" smtClean="0"/>
               <a:t>Fifth level</a:t>
             </a:r>
-            <a:endParaRPr lang="en-US"/>
+            <a:endParaRPr lang="pt-BR"/>
           </a:p>
         </p:txBody>
       </p:sp>
@@ -461,10 +461,10 @@
           <a:lstStyle/>
           <a:p>
             <a:fld id="{5BCAD085-E8A6-8845-BD4E-CB4CCA059FC4}" type="datetimeFigureOut">
-              <a:rPr lang="en-US" smtClean="0"/>
+              <a:rPr lang="pt-BR" smtClean="0"/>
               <a:t>1/27/13</a:t>
             </a:fld>
-            <a:endParaRPr lang="en-US"/>
+            <a:endParaRPr lang="pt-BR"/>
           </a:p>
         </p:txBody>
       </p:sp>
@@ -483,7 +483,7 @@
           <a:bodyPr/>
           <a:lstStyle/>
           <a:p>
-            <a:endParaRPr lang="en-US"/>
+            <a:endParaRPr lang="pt-BR"/>
           </a:p>
         </p:txBody>
       </p:sp>
@@ -503,10 +503,10 @@
           <a:lstStyle/>
           <a:p>
             <a:fld id="{C1FF6DA9-008F-8B48-92A6-B652298478BF}" type="slidenum">
-              <a:rPr lang="en-US" smtClean="0"/>
+              <a:rPr lang="pt-BR" smtClean="0"/>
               <a:t>‹#›</a:t>
             </a:fld>
-            <a:endParaRPr lang="en-US"/>
+            <a:endParaRPr lang="pt-BR"/>
           </a:p>
         </p:txBody>
       </p:sp>
@@ -561,10 +561,10 @@
           <a:lstStyle/>
           <a:p>
             <a:r>
-              <a:rPr lang="en-US" smtClean="0"/>
+              <a:rPr lang="pt-BR" smtClean="0"/>
               <a:t>Click to edit Master title style</a:t>
             </a:r>
-            <a:endParaRPr lang="en-US"/>
+            <a:endParaRPr lang="pt-BR"/>
           </a:p>
         </p:txBody>
       </p:sp>
@@ -590,38 +590,38 @@
           <a:p>
             <a:pPr lvl="0"/>
             <a:r>
-              <a:rPr lang="en-US" smtClean="0"/>
+              <a:rPr lang="pt-BR" smtClean="0"/>
               <a:t>Click to edit Master text styles</a:t>
             </a:r>
           </a:p>
           <a:p>
             <a:pPr lvl="1"/>
             <a:r>
-              <a:rPr lang="en-US" smtClean="0"/>
+              <a:rPr lang="pt-BR" smtClean="0"/>
               <a:t>Second level</a:t>
             </a:r>
           </a:p>
           <a:p>
             <a:pPr lvl="2"/>
             <a:r>
-              <a:rPr lang="en-US" smtClean="0"/>
+              <a:rPr lang="pt-BR" smtClean="0"/>
               <a:t>Third level</a:t>
             </a:r>
           </a:p>
           <a:p>
             <a:pPr lvl="3"/>
             <a:r>
-              <a:rPr lang="en-US" smtClean="0"/>
+              <a:rPr lang="pt-BR" smtClean="0"/>
               <a:t>Fourth level</a:t>
             </a:r>
           </a:p>
           <a:p>
             <a:pPr lvl="4"/>
             <a:r>
-              <a:rPr lang="en-US" smtClean="0"/>
+              <a:rPr lang="pt-BR" smtClean="0"/>
               <a:t>Fifth level</a:t>
             </a:r>
-            <a:endParaRPr lang="en-US"/>
+            <a:endParaRPr lang="pt-BR"/>
           </a:p>
         </p:txBody>
       </p:sp>
@@ -641,10 +641,10 @@
           <a:lstStyle/>
           <a:p>
             <a:fld id="{5BCAD085-E8A6-8845-BD4E-CB4CCA059FC4}" type="datetimeFigureOut">
-              <a:rPr lang="en-US" smtClean="0"/>
+              <a:rPr lang="pt-BR" smtClean="0"/>
               <a:t>1/27/13</a:t>
             </a:fld>
-            <a:endParaRPr lang="en-US"/>
+            <a:endParaRPr lang="pt-BR"/>
           </a:p>
         </p:txBody>
       </p:sp>
@@ -663,7 +663,7 @@
           <a:bodyPr/>
           <a:lstStyle/>
           <a:p>
-            <a:endParaRPr lang="en-US"/>
+            <a:endParaRPr lang="pt-BR"/>
           </a:p>
         </p:txBody>
       </p:sp>
@@ -683,10 +683,10 @@
           <a:lstStyle/>
           <a:p>
             <a:fld id="{C1FF6DA9-008F-8B48-92A6-B652298478BF}" type="slidenum">
-              <a:rPr lang="en-US" smtClean="0"/>
+              <a:rPr lang="pt-BR" smtClean="0"/>
               <a:t>‹#›</a:t>
             </a:fld>
-            <a:endParaRPr lang="en-US"/>
+            <a:endParaRPr lang="pt-BR"/>
           </a:p>
         </p:txBody>
       </p:sp>
@@ -736,10 +736,10 @@
           <a:lstStyle/>
           <a:p>
             <a:r>
-              <a:rPr lang="en-US" smtClean="0"/>
+              <a:rPr lang="pt-BR" smtClean="0"/>
               <a:t>Click to edit Master title style</a:t>
             </a:r>
-            <a:endParaRPr lang="en-US"/>
+            <a:endParaRPr lang="pt-BR"/>
           </a:p>
         </p:txBody>
       </p:sp>
@@ -760,38 +760,38 @@
           <a:p>
             <a:pPr lvl="0"/>
             <a:r>
-              <a:rPr lang="en-US" smtClean="0"/>
+              <a:rPr lang="pt-BR" smtClean="0"/>
               <a:t>Click to edit Master text styles</a:t>
             </a:r>
           </a:p>
           <a:p>
             <a:pPr lvl="1"/>
             <a:r>
-              <a:rPr lang="en-US" smtClean="0"/>
+              <a:rPr lang="pt-BR" smtClean="0"/>
               <a:t>Second level</a:t>
             </a:r>
           </a:p>
           <a:p>
             <a:pPr lvl="2"/>
             <a:r>
-              <a:rPr lang="en-US" smtClean="0"/>
+              <a:rPr lang="pt-BR" smtClean="0"/>
               <a:t>Third level</a:t>
             </a:r>
           </a:p>
           <a:p>
             <a:pPr lvl="3"/>
             <a:r>
-              <a:rPr lang="en-US" smtClean="0"/>
+              <a:rPr lang="pt-BR" smtClean="0"/>
               <a:t>Fourth level</a:t>
             </a:r>
           </a:p>
           <a:p>
             <a:pPr lvl="4"/>
             <a:r>
-              <a:rPr lang="en-US" smtClean="0"/>
+              <a:rPr lang="pt-BR" smtClean="0"/>
               <a:t>Fifth level</a:t>
             </a:r>
-            <a:endParaRPr lang="en-US"/>
+            <a:endParaRPr lang="pt-BR"/>
           </a:p>
         </p:txBody>
       </p:sp>
@@ -811,10 +811,10 @@
           <a:lstStyle/>
           <a:p>
             <a:fld id="{5BCAD085-E8A6-8845-BD4E-CB4CCA059FC4}" type="datetimeFigureOut">
-              <a:rPr lang="en-US" smtClean="0"/>
+              <a:rPr lang="pt-BR" smtClean="0"/>
               <a:t>1/27/13</a:t>
             </a:fld>
-            <a:endParaRPr lang="en-US"/>
+            <a:endParaRPr lang="pt-BR"/>
           </a:p>
         </p:txBody>
       </p:sp>
@@ -833,7 +833,7 @@
           <a:bodyPr/>
           <a:lstStyle/>
           <a:p>
-            <a:endParaRPr lang="en-US"/>
+            <a:endParaRPr lang="pt-BR"/>
           </a:p>
         </p:txBody>
       </p:sp>
@@ -853,10 +853,10 @@
           <a:lstStyle/>
           <a:p>
             <a:fld id="{C1FF6DA9-008F-8B48-92A6-B652298478BF}" type="slidenum">
-              <a:rPr lang="en-US" smtClean="0"/>
+              <a:rPr lang="pt-BR" smtClean="0"/>
               <a:t>‹#›</a:t>
             </a:fld>
-            <a:endParaRPr lang="en-US"/>
+            <a:endParaRPr lang="pt-BR"/>
           </a:p>
         </p:txBody>
       </p:sp>
@@ -915,10 +915,10 @@
           </a:lstStyle>
           <a:p>
             <a:r>
-              <a:rPr lang="en-US" smtClean="0"/>
+              <a:rPr lang="pt-BR" smtClean="0"/>
               <a:t>Click to edit Master title style</a:t>
             </a:r>
-            <a:endParaRPr lang="en-US"/>
+            <a:endParaRPr lang="pt-BR"/>
           </a:p>
         </p:txBody>
       </p:sp>
@@ -1035,7 +1035,7 @@
           <a:p>
             <a:pPr lvl="0"/>
             <a:r>
-              <a:rPr lang="en-US" smtClean="0"/>
+              <a:rPr lang="pt-BR" smtClean="0"/>
               <a:t>Click to edit Master text styles</a:t>
             </a:r>
           </a:p>
@@ -1057,10 +1057,10 @@
           <a:lstStyle/>
           <a:p>
             <a:fld id="{5BCAD085-E8A6-8845-BD4E-CB4CCA059FC4}" type="datetimeFigureOut">
-              <a:rPr lang="en-US" smtClean="0"/>
+              <a:rPr lang="pt-BR" smtClean="0"/>
               <a:t>1/27/13</a:t>
             </a:fld>
-            <a:endParaRPr lang="en-US"/>
+            <a:endParaRPr lang="pt-BR"/>
           </a:p>
         </p:txBody>
       </p:sp>
@@ -1079,7 +1079,7 @@
           <a:bodyPr/>
           <a:lstStyle/>
           <a:p>
-            <a:endParaRPr lang="en-US"/>
+            <a:endParaRPr lang="pt-BR"/>
           </a:p>
         </p:txBody>
       </p:sp>
@@ -1099,10 +1099,10 @@
           <a:lstStyle/>
           <a:p>
             <a:fld id="{C1FF6DA9-008F-8B48-92A6-B652298478BF}" type="slidenum">
-              <a:rPr lang="en-US" smtClean="0"/>
+              <a:rPr lang="pt-BR" smtClean="0"/>
               <a:t>‹#›</a:t>
             </a:fld>
-            <a:endParaRPr lang="en-US"/>
+            <a:endParaRPr lang="pt-BR"/>
           </a:p>
         </p:txBody>
       </p:sp>
@@ -1152,10 +1152,10 @@
           <a:lstStyle/>
           <a:p>
             <a:r>
-              <a:rPr lang="en-US" smtClean="0"/>
+              <a:rPr lang="pt-BR" smtClean="0"/>
               <a:t>Click to edit Master title style</a:t>
             </a:r>
-            <a:endParaRPr lang="en-US"/>
+            <a:endParaRPr lang="pt-BR"/>
           </a:p>
         </p:txBody>
       </p:sp>
@@ -1209,38 +1209,38 @@
           <a:p>
             <a:pPr lvl="0"/>
             <a:r>
-              <a:rPr lang="en-US" smtClean="0"/>
+              <a:rPr lang="pt-BR" smtClean="0"/>
               <a:t>Click to edit Master text styles</a:t>
             </a:r>
           </a:p>
           <a:p>
             <a:pPr lvl="1"/>
             <a:r>
-              <a:rPr lang="en-US" smtClean="0"/>
+              <a:rPr lang="pt-BR" smtClean="0"/>
               <a:t>Second level</a:t>
             </a:r>
           </a:p>
           <a:p>
             <a:pPr lvl="2"/>
             <a:r>
-              <a:rPr lang="en-US" smtClean="0"/>
+              <a:rPr lang="pt-BR" smtClean="0"/>
               <a:t>Third level</a:t>
             </a:r>
           </a:p>
           <a:p>
             <a:pPr lvl="3"/>
             <a:r>
-              <a:rPr lang="en-US" smtClean="0"/>
+              <a:rPr lang="pt-BR" smtClean="0"/>
               <a:t>Fourth level</a:t>
             </a:r>
           </a:p>
           <a:p>
             <a:pPr lvl="4"/>
             <a:r>
-              <a:rPr lang="en-US" smtClean="0"/>
+              <a:rPr lang="pt-BR" smtClean="0"/>
               <a:t>Fifth level</a:t>
             </a:r>
-            <a:endParaRPr lang="en-US"/>
+            <a:endParaRPr lang="pt-BR"/>
           </a:p>
         </p:txBody>
       </p:sp>
@@ -1294,38 +1294,38 @@
           <a:p>
             <a:pPr lvl="0"/>
             <a:r>
-              <a:rPr lang="en-US" smtClean="0"/>
+              <a:rPr lang="pt-BR" smtClean="0"/>
               <a:t>Click to edit Master text styles</a:t>
             </a:r>
           </a:p>
           <a:p>
             <a:pPr lvl="1"/>
             <a:r>
-              <a:rPr lang="en-US" smtClean="0"/>
+              <a:rPr lang="pt-BR" smtClean="0"/>
               <a:t>Second level</a:t>
             </a:r>
           </a:p>
           <a:p>
             <a:pPr lvl="2"/>
             <a:r>
-              <a:rPr lang="en-US" smtClean="0"/>
+              <a:rPr lang="pt-BR" smtClean="0"/>
               <a:t>Third level</a:t>
             </a:r>
           </a:p>
           <a:p>
             <a:pPr lvl="3"/>
             <a:r>
-              <a:rPr lang="en-US" smtClean="0"/>
+              <a:rPr lang="pt-BR" smtClean="0"/>
               <a:t>Fourth level</a:t>
             </a:r>
           </a:p>
           <a:p>
             <a:pPr lvl="4"/>
             <a:r>
-              <a:rPr lang="en-US" smtClean="0"/>
+              <a:rPr lang="pt-BR" smtClean="0"/>
               <a:t>Fifth level</a:t>
             </a:r>
-            <a:endParaRPr lang="en-US"/>
+            <a:endParaRPr lang="pt-BR"/>
           </a:p>
         </p:txBody>
       </p:sp>
@@ -1345,10 +1345,10 @@
           <a:lstStyle/>
           <a:p>
             <a:fld id="{5BCAD085-E8A6-8845-BD4E-CB4CCA059FC4}" type="datetimeFigureOut">
-              <a:rPr lang="en-US" smtClean="0"/>
+              <a:rPr lang="pt-BR" smtClean="0"/>
               <a:t>1/27/13</a:t>
             </a:fld>
-            <a:endParaRPr lang="en-US"/>
+            <a:endParaRPr lang="pt-BR"/>
           </a:p>
         </p:txBody>
       </p:sp>
@@ -1367,7 +1367,7 @@
           <a:bodyPr/>
           <a:lstStyle/>
           <a:p>
-            <a:endParaRPr lang="en-US"/>
+            <a:endParaRPr lang="pt-BR"/>
           </a:p>
         </p:txBody>
       </p:sp>
@@ -1387,10 +1387,10 @@
           <a:lstStyle/>
           <a:p>
             <a:fld id="{C1FF6DA9-008F-8B48-92A6-B652298478BF}" type="slidenum">
-              <a:rPr lang="en-US" smtClean="0"/>
+              <a:rPr lang="pt-BR" smtClean="0"/>
               <a:t>‹#›</a:t>
             </a:fld>
-            <a:endParaRPr lang="en-US"/>
+            <a:endParaRPr lang="pt-BR"/>
           </a:p>
         </p:txBody>
       </p:sp>
@@ -1444,10 +1444,10 @@
           </a:lstStyle>
           <a:p>
             <a:r>
-              <a:rPr lang="en-US" smtClean="0"/>
+              <a:rPr lang="pt-BR" smtClean="0"/>
               <a:t>Click to edit Master title style</a:t>
             </a:r>
-            <a:endParaRPr lang="en-US"/>
+            <a:endParaRPr lang="pt-BR"/>
           </a:p>
         </p:txBody>
       </p:sp>
@@ -1510,7 +1510,7 @@
           <a:p>
             <a:pPr lvl="0"/>
             <a:r>
-              <a:rPr lang="en-US" smtClean="0"/>
+              <a:rPr lang="pt-BR" smtClean="0"/>
               <a:t>Click to edit Master text styles</a:t>
             </a:r>
           </a:p>
@@ -1566,38 +1566,38 @@
           <a:p>
             <a:pPr lvl="0"/>
             <a:r>
-              <a:rPr lang="en-US" smtClean="0"/>
+              <a:rPr lang="pt-BR" smtClean="0"/>
               <a:t>Click to edit Master text styles</a:t>
             </a:r>
           </a:p>
           <a:p>
             <a:pPr lvl="1"/>
             <a:r>
-              <a:rPr lang="en-US" smtClean="0"/>
+              <a:rPr lang="pt-BR" smtClean="0"/>
               <a:t>Second level</a:t>
             </a:r>
           </a:p>
           <a:p>
             <a:pPr lvl="2"/>
             <a:r>
-              <a:rPr lang="en-US" smtClean="0"/>
+              <a:rPr lang="pt-BR" smtClean="0"/>
               <a:t>Third level</a:t>
             </a:r>
           </a:p>
           <a:p>
             <a:pPr lvl="3"/>
             <a:r>
-              <a:rPr lang="en-US" smtClean="0"/>
+              <a:rPr lang="pt-BR" smtClean="0"/>
               <a:t>Fourth level</a:t>
             </a:r>
           </a:p>
           <a:p>
             <a:pPr lvl="4"/>
             <a:r>
-              <a:rPr lang="en-US" smtClean="0"/>
+              <a:rPr lang="pt-BR" smtClean="0"/>
               <a:t>Fifth level</a:t>
             </a:r>
-            <a:endParaRPr lang="en-US"/>
+            <a:endParaRPr lang="pt-BR"/>
           </a:p>
         </p:txBody>
       </p:sp>
@@ -1660,7 +1660,7 @@
           <a:p>
             <a:pPr lvl="0"/>
             <a:r>
-              <a:rPr lang="en-US" smtClean="0"/>
+              <a:rPr lang="pt-BR" smtClean="0"/>
               <a:t>Click to edit Master text styles</a:t>
             </a:r>
           </a:p>
@@ -1716,38 +1716,38 @@
           <a:p>
             <a:pPr lvl="0"/>
             <a:r>
-              <a:rPr lang="en-US" smtClean="0"/>
+              <a:rPr lang="pt-BR" smtClean="0"/>
               <a:t>Click to edit Master text styles</a:t>
             </a:r>
           </a:p>
           <a:p>
             <a:pPr lvl="1"/>
             <a:r>
-              <a:rPr lang="en-US" smtClean="0"/>
+              <a:rPr lang="pt-BR" smtClean="0"/>
               <a:t>Second level</a:t>
             </a:r>
           </a:p>
           <a:p>
             <a:pPr lvl="2"/>
             <a:r>
-              <a:rPr lang="en-US" smtClean="0"/>
+              <a:rPr lang="pt-BR" smtClean="0"/>
               <a:t>Third level</a:t>
             </a:r>
           </a:p>
           <a:p>
             <a:pPr lvl="3"/>
             <a:r>
-              <a:rPr lang="en-US" smtClean="0"/>
+              <a:rPr lang="pt-BR" smtClean="0"/>
               <a:t>Fourth level</a:t>
             </a:r>
           </a:p>
           <a:p>
             <a:pPr lvl="4"/>
             <a:r>
-              <a:rPr lang="en-US" smtClean="0"/>
+              <a:rPr lang="pt-BR" smtClean="0"/>
               <a:t>Fifth level</a:t>
             </a:r>
-            <a:endParaRPr lang="en-US"/>
+            <a:endParaRPr lang="pt-BR"/>
           </a:p>
         </p:txBody>
       </p:sp>
@@ -1767,10 +1767,10 @@
           <a:lstStyle/>
           <a:p>
             <a:fld id="{5BCAD085-E8A6-8845-BD4E-CB4CCA059FC4}" type="datetimeFigureOut">
-              <a:rPr lang="en-US" smtClean="0"/>
+              <a:rPr lang="pt-BR" smtClean="0"/>
               <a:t>1/27/13</a:t>
             </a:fld>
-            <a:endParaRPr lang="en-US"/>
+            <a:endParaRPr lang="pt-BR"/>
           </a:p>
         </p:txBody>
       </p:sp>
@@ -1789,7 +1789,7 @@
           <a:bodyPr/>
           <a:lstStyle/>
           <a:p>
-            <a:endParaRPr lang="en-US"/>
+            <a:endParaRPr lang="pt-BR"/>
           </a:p>
         </p:txBody>
       </p:sp>
@@ -1809,10 +1809,10 @@
           <a:lstStyle/>
           <a:p>
             <a:fld id="{C1FF6DA9-008F-8B48-92A6-B652298478BF}" type="slidenum">
-              <a:rPr lang="en-US" smtClean="0"/>
+              <a:rPr lang="pt-BR" smtClean="0"/>
               <a:t>‹#›</a:t>
             </a:fld>
-            <a:endParaRPr lang="en-US"/>
+            <a:endParaRPr lang="pt-BR"/>
           </a:p>
         </p:txBody>
       </p:sp>
@@ -1862,10 +1862,10 @@
           <a:lstStyle/>
           <a:p>
             <a:r>
-              <a:rPr lang="en-US" smtClean="0"/>
+              <a:rPr lang="pt-BR" smtClean="0"/>
               <a:t>Click to edit Master title style</a:t>
             </a:r>
-            <a:endParaRPr lang="en-US"/>
+            <a:endParaRPr lang="pt-BR"/>
           </a:p>
         </p:txBody>
       </p:sp>
@@ -1885,10 +1885,10 @@
           <a:lstStyle/>
           <a:p>
             <a:fld id="{5BCAD085-E8A6-8845-BD4E-CB4CCA059FC4}" type="datetimeFigureOut">
-              <a:rPr lang="en-US" smtClean="0"/>
+              <a:rPr lang="pt-BR" smtClean="0"/>
               <a:t>1/27/13</a:t>
             </a:fld>
-            <a:endParaRPr lang="en-US"/>
+            <a:endParaRPr lang="pt-BR"/>
           </a:p>
         </p:txBody>
       </p:sp>
@@ -1907,7 +1907,7 @@
           <a:bodyPr/>
           <a:lstStyle/>
           <a:p>
-            <a:endParaRPr lang="en-US"/>
+            <a:endParaRPr lang="pt-BR"/>
           </a:p>
         </p:txBody>
       </p:sp>
@@ -1927,10 +1927,10 @@
           <a:lstStyle/>
           <a:p>
             <a:fld id="{C1FF6DA9-008F-8B48-92A6-B652298478BF}" type="slidenum">
-              <a:rPr lang="en-US" smtClean="0"/>
+              <a:rPr lang="pt-BR" smtClean="0"/>
               <a:t>‹#›</a:t>
             </a:fld>
-            <a:endParaRPr lang="en-US"/>
+            <a:endParaRPr lang="pt-BR"/>
           </a:p>
         </p:txBody>
       </p:sp>
@@ -1980,10 +1980,10 @@
           <a:lstStyle/>
           <a:p>
             <a:fld id="{5BCAD085-E8A6-8845-BD4E-CB4CCA059FC4}" type="datetimeFigureOut">
-              <a:rPr lang="en-US" smtClean="0"/>
+              <a:rPr lang="pt-BR" smtClean="0"/>
               <a:t>1/27/13</a:t>
             </a:fld>
-            <a:endParaRPr lang="en-US"/>
+            <a:endParaRPr lang="pt-BR"/>
           </a:p>
         </p:txBody>
       </p:sp>
@@ -2002,7 +2002,7 @@
           <a:bodyPr/>
           <a:lstStyle/>
           <a:p>
-            <a:endParaRPr lang="en-US"/>
+            <a:endParaRPr lang="pt-BR"/>
           </a:p>
         </p:txBody>
       </p:sp>
@@ -2022,10 +2022,10 @@
           <a:lstStyle/>
           <a:p>
             <a:fld id="{C1FF6DA9-008F-8B48-92A6-B652298478BF}" type="slidenum">
-              <a:rPr lang="en-US" smtClean="0"/>
+              <a:rPr lang="pt-BR" smtClean="0"/>
               <a:t>‹#›</a:t>
             </a:fld>
-            <a:endParaRPr lang="en-US"/>
+            <a:endParaRPr lang="pt-BR"/>
           </a:p>
         </p:txBody>
       </p:sp>
@@ -2084,10 +2084,10 @@
           </a:lstStyle>
           <a:p>
             <a:r>
-              <a:rPr lang="en-US" smtClean="0"/>
+              <a:rPr lang="pt-BR" smtClean="0"/>
               <a:t>Click to edit Master title style</a:t>
             </a:r>
-            <a:endParaRPr lang="en-US"/>
+            <a:endParaRPr lang="pt-BR"/>
           </a:p>
         </p:txBody>
       </p:sp>
@@ -2141,38 +2141,38 @@
           <a:p>
             <a:pPr lvl="0"/>
             <a:r>
-              <a:rPr lang="en-US" smtClean="0"/>
+              <a:rPr lang="pt-BR" smtClean="0"/>
               <a:t>Click to edit Master text styles</a:t>
             </a:r>
           </a:p>
           <a:p>
             <a:pPr lvl="1"/>
             <a:r>
-              <a:rPr lang="en-US" smtClean="0"/>
+              <a:rPr lang="pt-BR" smtClean="0"/>
               <a:t>Second level</a:t>
             </a:r>
           </a:p>
           <a:p>
             <a:pPr lvl="2"/>
             <a:r>
-              <a:rPr lang="en-US" smtClean="0"/>
+              <a:rPr lang="pt-BR" smtClean="0"/>
               <a:t>Third level</a:t>
             </a:r>
           </a:p>
           <a:p>
             <a:pPr lvl="3"/>
             <a:r>
-              <a:rPr lang="en-US" smtClean="0"/>
+              <a:rPr lang="pt-BR" smtClean="0"/>
               <a:t>Fourth level</a:t>
             </a:r>
           </a:p>
           <a:p>
             <a:pPr lvl="4"/>
             <a:r>
-              <a:rPr lang="en-US" smtClean="0"/>
+              <a:rPr lang="pt-BR" smtClean="0"/>
               <a:t>Fifth level</a:t>
             </a:r>
-            <a:endParaRPr lang="en-US"/>
+            <a:endParaRPr lang="pt-BR"/>
           </a:p>
         </p:txBody>
       </p:sp>
@@ -2235,7 +2235,7 @@
           <a:p>
             <a:pPr lvl="0"/>
             <a:r>
-              <a:rPr lang="en-US" smtClean="0"/>
+              <a:rPr lang="pt-BR" smtClean="0"/>
               <a:t>Click to edit Master text styles</a:t>
             </a:r>
           </a:p>
@@ -2257,10 +2257,10 @@
           <a:lstStyle/>
           <a:p>
             <a:fld id="{5BCAD085-E8A6-8845-BD4E-CB4CCA059FC4}" type="datetimeFigureOut">
-              <a:rPr lang="en-US" smtClean="0"/>
+              <a:rPr lang="pt-BR" smtClean="0"/>
               <a:t>1/27/13</a:t>
             </a:fld>
-            <a:endParaRPr lang="en-US"/>
+            <a:endParaRPr lang="pt-BR"/>
           </a:p>
         </p:txBody>
       </p:sp>
@@ -2279,7 +2279,7 @@
           <a:bodyPr/>
           <a:lstStyle/>
           <a:p>
-            <a:endParaRPr lang="en-US"/>
+            <a:endParaRPr lang="pt-BR"/>
           </a:p>
         </p:txBody>
       </p:sp>
@@ -2299,10 +2299,10 @@
           <a:lstStyle/>
           <a:p>
             <a:fld id="{C1FF6DA9-008F-8B48-92A6-B652298478BF}" type="slidenum">
-              <a:rPr lang="en-US" smtClean="0"/>
+              <a:rPr lang="pt-BR" smtClean="0"/>
               <a:t>‹#›</a:t>
             </a:fld>
-            <a:endParaRPr lang="en-US"/>
+            <a:endParaRPr lang="pt-BR"/>
           </a:p>
         </p:txBody>
       </p:sp>
@@ -2361,10 +2361,10 @@
           </a:lstStyle>
           <a:p>
             <a:r>
-              <a:rPr lang="en-US" smtClean="0"/>
+              <a:rPr lang="pt-BR" smtClean="0"/>
               <a:t>Click to edit Master title style</a:t>
             </a:r>
-            <a:endParaRPr lang="en-US"/>
+            <a:endParaRPr lang="pt-BR"/>
           </a:p>
         </p:txBody>
       </p:sp>
@@ -2425,7 +2425,7 @@
             </a:lvl9pPr>
           </a:lstStyle>
           <a:p>
-            <a:endParaRPr lang="en-US"/>
+            <a:endParaRPr lang="pt-BR"/>
           </a:p>
         </p:txBody>
       </p:sp>
@@ -2488,7 +2488,7 @@
           <a:p>
             <a:pPr lvl="0"/>
             <a:r>
-              <a:rPr lang="en-US" smtClean="0"/>
+              <a:rPr lang="pt-BR" smtClean="0"/>
               <a:t>Click to edit Master text styles</a:t>
             </a:r>
           </a:p>
@@ -2510,10 +2510,10 @@
           <a:lstStyle/>
           <a:p>
             <a:fld id="{5BCAD085-E8A6-8845-BD4E-CB4CCA059FC4}" type="datetimeFigureOut">
-              <a:rPr lang="en-US" smtClean="0"/>
+              <a:rPr lang="pt-BR" smtClean="0"/>
               <a:t>1/27/13</a:t>
             </a:fld>
-            <a:endParaRPr lang="en-US"/>
+            <a:endParaRPr lang="pt-BR"/>
           </a:p>
         </p:txBody>
       </p:sp>
@@ -2532,7 +2532,7 @@
           <a:bodyPr/>
           <a:lstStyle/>
           <a:p>
-            <a:endParaRPr lang="en-US"/>
+            <a:endParaRPr lang="pt-BR"/>
           </a:p>
         </p:txBody>
       </p:sp>
@@ -2552,10 +2552,10 @@
           <a:lstStyle/>
           <a:p>
             <a:fld id="{C1FF6DA9-008F-8B48-92A6-B652298478BF}" type="slidenum">
-              <a:rPr lang="en-US" smtClean="0"/>
+              <a:rPr lang="pt-BR" smtClean="0"/>
               <a:t>‹#›</a:t>
             </a:fld>
-            <a:endParaRPr lang="en-US"/>
+            <a:endParaRPr lang="pt-BR"/>
           </a:p>
         </p:txBody>
       </p:sp>
@@ -2620,10 +2620,10 @@
           <a:lstStyle/>
           <a:p>
             <a:r>
-              <a:rPr lang="en-US" smtClean="0"/>
+              <a:rPr lang="pt-BR" smtClean="0"/>
               <a:t>Click to edit Master title style</a:t>
             </a:r>
-            <a:endParaRPr lang="en-US"/>
+            <a:endParaRPr lang="pt-BR"/>
           </a:p>
         </p:txBody>
       </p:sp>
@@ -2654,38 +2654,38 @@
           <a:p>
             <a:pPr lvl="0"/>
             <a:r>
-              <a:rPr lang="en-US" smtClean="0"/>
+              <a:rPr lang="pt-BR" smtClean="0"/>
               <a:t>Click to edit Master text styles</a:t>
             </a:r>
           </a:p>
           <a:p>
             <a:pPr lvl="1"/>
             <a:r>
-              <a:rPr lang="en-US" smtClean="0"/>
+              <a:rPr lang="pt-BR" smtClean="0"/>
               <a:t>Second level</a:t>
             </a:r>
           </a:p>
           <a:p>
             <a:pPr lvl="2"/>
             <a:r>
-              <a:rPr lang="en-US" smtClean="0"/>
+              <a:rPr lang="pt-BR" smtClean="0"/>
               <a:t>Third level</a:t>
             </a:r>
           </a:p>
           <a:p>
             <a:pPr lvl="3"/>
             <a:r>
-              <a:rPr lang="en-US" smtClean="0"/>
+              <a:rPr lang="pt-BR" smtClean="0"/>
               <a:t>Fourth level</a:t>
             </a:r>
           </a:p>
           <a:p>
             <a:pPr lvl="4"/>
             <a:r>
-              <a:rPr lang="en-US" smtClean="0"/>
+              <a:rPr lang="pt-BR" smtClean="0"/>
               <a:t>Fifth level</a:t>
             </a:r>
-            <a:endParaRPr lang="en-US"/>
+            <a:endParaRPr lang="pt-BR"/>
           </a:p>
         </p:txBody>
       </p:sp>
@@ -2723,10 +2723,10 @@
           </a:lstStyle>
           <a:p>
             <a:fld id="{5BCAD085-E8A6-8845-BD4E-CB4CCA059FC4}" type="datetimeFigureOut">
-              <a:rPr lang="en-US" smtClean="0"/>
+              <a:rPr lang="pt-BR" smtClean="0"/>
               <a:t>1/27/13</a:t>
             </a:fld>
-            <a:endParaRPr lang="en-US"/>
+            <a:endParaRPr lang="pt-BR"/>
           </a:p>
         </p:txBody>
       </p:sp>
@@ -2763,7 +2763,7 @@
             </a:lvl1pPr>
           </a:lstStyle>
           <a:p>
-            <a:endParaRPr lang="en-US"/>
+            <a:endParaRPr lang="pt-BR"/>
           </a:p>
         </p:txBody>
       </p:sp>
@@ -2801,10 +2801,10 @@
           </a:lstStyle>
           <a:p>
             <a:fld id="{C1FF6DA9-008F-8B48-92A6-B652298478BF}" type="slidenum">
-              <a:rPr lang="en-US" smtClean="0"/>
+              <a:rPr lang="pt-BR" smtClean="0"/>
               <a:t>‹#›</a:t>
             </a:fld>
-            <a:endParaRPr lang="en-US"/>
+            <a:endParaRPr lang="pt-BR"/>
           </a:p>
         </p:txBody>
       </p:sp>
@@ -2985,7 +2985,7 @@
     </p:bodyStyle>
     <p:otherStyle>
       <a:defPPr>
-        <a:defRPr lang="en-US"/>
+        <a:defRPr lang="pt-BR"/>
       </a:defPPr>
       <a:lvl1pPr marL="0" algn="l" defTabSz="457200" rtl="0" eaLnBrk="1" latinLnBrk="0" hangingPunct="1">
         <a:defRPr sz="1800" kern="1200">
@@ -3238,7 +3238,7 @@
           <a:p>
             <a:pPr algn="l"/>
             <a:r>
-              <a:rPr sz="4400" b="1">
+              <a:rPr sz="4400" b="1" lang="pt-BR">
                 <a:solidFill>
                   <a:srgbClr val="FFFFFF"/>
                 </a:solidFill>
@@ -3273,7 +3273,7 @@
           <a:p>
             <a:pPr algn="l"/>
             <a:r>
-              <a:rPr sz="2000" b="0">
+              <a:rPr sz="2000" b="0" lang="pt-BR">
                 <a:solidFill>
                   <a:srgbClr val="C9D0F0"/>
                 </a:solidFill>
@@ -3308,7 +3308,7 @@
           <a:p>
             <a:pPr algn="l"/>
             <a:r>
-              <a:rPr sz="1100" b="0">
+              <a:rPr sz="1100" b="0" lang="pt-BR">
                 <a:solidFill>
                   <a:srgbClr val="8E99D6"/>
                 </a:solidFill>
@@ -3414,7 +3414,7 @@
           <a:p>
             <a:pPr algn="l"/>
             <a:r>
-              <a:rPr sz="3000" b="1">
+              <a:rPr sz="3000" b="1" lang="pt-BR">
                 <a:solidFill>
                   <a:srgbClr val="0D176E"/>
                 </a:solidFill>
@@ -3568,7 +3568,7 @@
           <a:p>
             <a:pPr algn="l"/>
             <a:r>
-              <a:rPr sz="2400" b="0">
+              <a:rPr sz="2400" b="0" lang="pt-BR">
                 <a:solidFill>
                   <a:srgbClr val="1B2140"/>
                 </a:solidFill>
@@ -3655,7 +3655,7 @@
           <a:p>
             <a:pPr algn="l"/>
             <a:r>
-              <a:rPr sz="2400" b="0">
+              <a:rPr sz="2400" b="0" lang="pt-BR">
                 <a:solidFill>
                   <a:srgbClr val="1B2140"/>
                 </a:solidFill>
@@ -3742,7 +3742,7 @@
           <a:p>
             <a:pPr algn="l"/>
             <a:r>
-              <a:rPr sz="2400" b="0">
+              <a:rPr sz="2400" b="0" lang="pt-BR">
                 <a:solidFill>
                   <a:srgbClr val="1B2140"/>
                 </a:solidFill>
@@ -3848,7 +3848,7 @@
           <a:p>
             <a:pPr algn="l"/>
             <a:r>
-              <a:rPr sz="3000" b="1">
+              <a:rPr sz="3000" b="1" lang="pt-BR">
                 <a:solidFill>
                   <a:srgbClr val="0D176E"/>
                 </a:solidFill>
@@ -3995,7 +3995,7 @@
           <a:p>
             <a:pPr algn="l"/>
             <a:r>
-              <a:rPr sz="1400" b="1">
+              <a:rPr sz="1400" b="1" lang="pt-BR">
                 <a:solidFill>
                   <a:srgbClr val="2A3796"/>
                 </a:solidFill>
@@ -4030,7 +4030,7 @@
           <a:p>
             <a:pPr algn="l"/>
             <a:r>
-              <a:rPr sz="4000" b="1">
+              <a:rPr sz="4000" b="1" lang="pt-BR">
                 <a:solidFill>
                   <a:srgbClr val="0D176E"/>
                 </a:solidFill>
@@ -4110,7 +4110,7 @@
           <a:p>
             <a:pPr algn="l"/>
             <a:r>
-              <a:rPr sz="1400" b="1">
+              <a:rPr sz="1400" b="1" lang="pt-BR">
                 <a:solidFill>
                   <a:srgbClr val="2A3796"/>
                 </a:solidFill>
@@ -4145,7 +4145,7 @@
           <a:p>
             <a:pPr algn="l"/>
             <a:r>
-              <a:rPr sz="4000" b="1">
+              <a:rPr sz="4000" b="1" lang="pt-BR">
                 <a:solidFill>
                   <a:srgbClr val="0D176E"/>
                 </a:solidFill>
@@ -4225,7 +4225,7 @@
           <a:p>
             <a:pPr algn="l"/>
             <a:r>
-              <a:rPr sz="1400" b="1">
+              <a:rPr sz="1400" b="1" lang="pt-BR">
                 <a:solidFill>
                   <a:srgbClr val="2A3796"/>
                 </a:solidFill>
@@ -4260,7 +4260,7 @@
           <a:p>
             <a:pPr algn="l"/>
             <a:r>
-              <a:rPr sz="4000" b="1">
+              <a:rPr sz="4000" b="1" lang="pt-BR">
                 <a:solidFill>
                   <a:srgbClr val="0D176E"/>
                 </a:solidFill>
@@ -4295,7 +4295,7 @@
           <a:p>
             <a:pPr algn="l"/>
             <a:r>
-              <a:rPr sz="1800" b="0">
+              <a:rPr sz="1800" b="0" lang="pt-BR">
                 <a:solidFill>
                   <a:srgbClr val="5C6480"/>
                 </a:solidFill>
@@ -4401,7 +4401,7 @@
           <a:p>
             <a:pPr algn="l"/>
             <a:r>
-              <a:rPr sz="3000" b="1">
+              <a:rPr sz="3000" b="1" lang="pt-BR">
                 <a:solidFill>
                   <a:srgbClr val="0D176E"/>
                 </a:solidFill>
@@ -4507,7 +4507,7 @@
               </a:spcAft>
             </a:pPr>
             <a:r>
-              <a:rPr sz="2400">
+              <a:rPr sz="2400" lang="pt-BR">
                 <a:solidFill>
                   <a:srgbClr val="1B2140"/>
                 </a:solidFill>
@@ -4523,7 +4523,7 @@
               </a:spcAft>
             </a:pPr>
             <a:r>
-              <a:rPr sz="2400">
+              <a:rPr sz="2400" lang="pt-BR">
                 <a:solidFill>
                   <a:srgbClr val="1B2140"/>
                 </a:solidFill>
@@ -4539,7 +4539,7 @@
               </a:spcAft>
             </a:pPr>
             <a:r>
-              <a:rPr sz="2400">
+              <a:rPr sz="2400" lang="pt-BR">
                 <a:solidFill>
                   <a:srgbClr val="1B2140"/>
                 </a:solidFill>
@@ -4714,7 +4714,7 @@
           <a:p>
             <a:pPr algn="ctr"/>
             <a:r>
-              <a:rPr sz="3600" b="1">
+              <a:rPr sz="3600" b="1" lang="pt-BR">
                 <a:solidFill>
                   <a:srgbClr val="FFFFFF"/>
                 </a:solidFill>

</xml_diff>